<commit_message>
exp/op-fm-survey: label each paper slide with its full title
yilin found the abbreviations hard to remember. Added a TITLES map +
make_title() so each of the 9 per-paper slides is headed by the paper's
full article name (verbatim from the YIL-114/115 full-text reads).
Re-rendered + re-attached to YIL-113.

Co-Authored-By: Claude Opus 4.8 <noreply@anthropic.com>
</commit_message>
<xml_diff>
--- a/experiments/20260714-op-fm-survey/op_fm_survey_slides.pptx
+++ b/experiments/20260714-op-fm-survey/op_fm_survey_slides.pptx
@@ -13258,6 +13258,18 @@
           <a:p>
             <a:pPr marL="285750" indent="-285750">
               <a:buFont typeface="Arial" panose="020B0604020202020204" pitchFamily="34" charset="0"/>
+              <a:buNone/>
+            </a:pPr>
+            <a:r>
+              <a:rPr lang="en-US" altLang="zh-CN" dirty="0" b="1" sz="1500">
+                <a:latin typeface="Amasis MT Pro" panose="02040504050005020304" pitchFamily="18" charset="0"/>
+              </a:rPr>
+              <a:t>Attention, Learn to Solve Routing Problems!  (arXiv:1803.08475)</a:t>
+            </a:r>
+          </a:p>
+          <a:p>
+            <a:pPr marL="285750" indent="-285750">
+              <a:buFont typeface="Arial" panose="020B0604020202020204" pitchFamily="34" charset="0"/>
               <a:buChar char="•"/>
             </a:pPr>
             <a:r>
@@ -13541,6 +13553,18 @@
           <a:p>
             <a:pPr marL="285750" indent="-285750">
               <a:buFont typeface="Arial" panose="020B0604020202020204" pitchFamily="34" charset="0"/>
+              <a:buNone/>
+            </a:pPr>
+            <a:r>
+              <a:rPr lang="en-US" altLang="zh-CN" dirty="0" b="1" sz="1500">
+                <a:latin typeface="Amasis MT Pro" panose="02040504050005020304" pitchFamily="18" charset="0"/>
+              </a:rPr>
+              <a:t>POMO: Policy Optimization with Multiple Optima for Reinforcement Learning  (arXiv:2010.16011)</a:t>
+            </a:r>
+          </a:p>
+          <a:p>
+            <a:pPr marL="285750" indent="-285750">
+              <a:buFont typeface="Arial" panose="020B0604020202020204" pitchFamily="34" charset="0"/>
               <a:buChar char="•"/>
             </a:pPr>
             <a:r>
@@ -13812,6 +13836,18 @@
           <a:p>
             <a:pPr marL="285750" indent="-285750">
               <a:buFont typeface="Arial" panose="020B0604020202020204" pitchFamily="34" charset="0"/>
+              <a:buNone/>
+            </a:pPr>
+            <a:r>
+              <a:rPr lang="en-US" altLang="zh-CN" dirty="0" b="1" sz="1500">
+                <a:latin typeface="Amasis MT Pro" panose="02040504050005020304" pitchFamily="18" charset="0"/>
+              </a:rPr>
+              <a:t>TOP-Former: A Multi-Agent Transformer Approach for the Team Orienteering Problem  (arXiv:2311.18662)</a:t>
+            </a:r>
+          </a:p>
+          <a:p>
+            <a:pPr marL="285750" indent="-285750">
+              <a:buFont typeface="Arial" panose="020B0604020202020204" pitchFamily="34" charset="0"/>
               <a:buChar char="•"/>
             </a:pPr>
             <a:r>
@@ -14107,6 +14143,18 @@
           <a:p>
             <a:pPr marL="285750" indent="-285750">
               <a:buFont typeface="Arial" panose="020B0604020202020204" pitchFamily="34" charset="0"/>
+              <a:buNone/>
+            </a:pPr>
+            <a:r>
+              <a:rPr lang="en-US" altLang="zh-CN" dirty="0" b="1" sz="1500">
+                <a:latin typeface="Amasis MT Pro" panose="02040504050005020304" pitchFamily="18" charset="0"/>
+              </a:rPr>
+              <a:t>Multi-Start Team Orienteering Problem for UAS Mission Re-Planning with Data-Efficient Deep RL  (arXiv:2303.01963)</a:t>
+            </a:r>
+          </a:p>
+          <a:p>
+            <a:pPr marL="285750" indent="-285750">
+              <a:buFont typeface="Arial" panose="020B0604020202020204" pitchFamily="34" charset="0"/>
               <a:buChar char="•"/>
             </a:pPr>
             <a:r>
@@ -14402,6 +14450,18 @@
           <a:p>
             <a:pPr marL="285750" indent="-285750">
               <a:buFont typeface="Arial" panose="020B0604020202020204" pitchFamily="34" charset="0"/>
+              <a:buNone/>
+            </a:pPr>
+            <a:r>
+              <a:rPr lang="en-US" altLang="zh-CN" dirty="0" b="1" sz="1500">
+                <a:latin typeface="Amasis MT Pro" panose="02040504050005020304" pitchFamily="18" charset="0"/>
+              </a:rPr>
+              <a:t>The Dynamic Team Orienteering Problem in Spatial Crowdsourcing: A Scenario Sampling Approach  (arXiv:2601.11010)</a:t>
+            </a:r>
+          </a:p>
+          <a:p>
+            <a:pPr marL="285750" indent="-285750">
+              <a:buFont typeface="Arial" panose="020B0604020202020204" pitchFamily="34" charset="0"/>
               <a:buChar char="•"/>
             </a:pPr>
             <a:r>
@@ -14658,6 +14718,18 @@
             <a:spAutoFit/>
           </a:bodyPr>
           <a:lstStyle/>
+          <a:p>
+            <a:pPr marL="285750" indent="-285750">
+              <a:buFont typeface="Arial" panose="020B0604020202020204" pitchFamily="34" charset="0"/>
+              <a:buNone/>
+            </a:pPr>
+            <a:r>
+              <a:rPr lang="en-US" altLang="zh-CN" dirty="0" b="1" sz="1500">
+                <a:latin typeface="Amasis MT Pro" panose="02040504050005020304" pitchFamily="18" charset="0"/>
+              </a:rPr>
+              <a:t>RouteFinder: Towards Foundation Models for Vehicle Routing Problems  (arXiv:2406.15007)</a:t>
+            </a:r>
+          </a:p>
           <a:p>
             <a:pPr marL="285750" indent="-285750">
               <a:buFont typeface="Arial" panose="020B0604020202020204" pitchFamily="34" charset="0"/>
@@ -15029,6 +15101,18 @@
           <a:p>
             <a:pPr marL="285750" indent="-285750">
               <a:buFont typeface="Arial" panose="020B0604020202020204" pitchFamily="34" charset="0"/>
+              <a:buNone/>
+            </a:pPr>
+            <a:r>
+              <a:rPr lang="en-US" altLang="zh-CN" dirty="0" b="1" sz="1500">
+                <a:latin typeface="Amasis MT Pro" panose="02040504050005020304" pitchFamily="18" charset="0"/>
+              </a:rPr>
+              <a:t>Learning to Deliver: A Foundation Model for the Montreal Capacitated Vehicle Routing Problem  (arXiv:2403.00026)</a:t>
+            </a:r>
+          </a:p>
+          <a:p>
+            <a:pPr marL="285750" indent="-285750">
+              <a:buFont typeface="Arial" panose="020B0604020202020204" pitchFamily="34" charset="0"/>
               <a:buChar char="•"/>
             </a:pPr>
             <a:r>
@@ -15288,6 +15372,18 @@
           <a:p>
             <a:pPr marL="285750" indent="-285750">
               <a:buFont typeface="Arial" panose="020B0604020202020204" pitchFamily="34" charset="0"/>
+              <a:buNone/>
+            </a:pPr>
+            <a:r>
+              <a:rPr lang="en-US" altLang="zh-CN" dirty="0" b="1" sz="1500">
+                <a:latin typeface="Amasis MT Pro" panose="02040504050005020304" pitchFamily="18" charset="0"/>
+              </a:rPr>
+              <a:t>GOAL: A Generalist Combinatorial Optimization Agent Learner  (arXiv:2406.15079)</a:t>
+            </a:r>
+          </a:p>
+          <a:p>
+            <a:pPr marL="285750" indent="-285750">
+              <a:buFont typeface="Arial" panose="020B0604020202020204" pitchFamily="34" charset="0"/>
               <a:buChar char="•"/>
             </a:pPr>
             <a:r>
@@ -15532,6 +15628,18 @@
             <a:spAutoFit/>
           </a:bodyPr>
           <a:lstStyle/>
+          <a:p>
+            <a:pPr marL="285750" indent="-285750">
+              <a:buFont typeface="Arial" panose="020B0604020202020204" pitchFamily="34" charset="0"/>
+              <a:buNone/>
+            </a:pPr>
+            <a:r>
+              <a:rPr lang="en-US" altLang="zh-CN" dirty="0" b="1" sz="1500">
+                <a:latin typeface="Amasis MT Pro" panose="02040504050005020304" pitchFamily="18" charset="0"/>
+              </a:rPr>
+              <a:t>On Unified Combinatorial Optimization via Problem Reduction to Matrix-Encoded General TSP  (OpenReview yEwakMNIex)</a:t>
+            </a:r>
+          </a:p>
           <a:p>
             <a:pPr marL="285750" indent="-285750">
               <a:buFont typeface="Arial" panose="020B0604020202020204" pitchFamily="34" charset="0"/>

</xml_diff>